<commit_message>
feat: PARVAT NETRA Phase 1-13 complete baseline
</commit_message>
<xml_diff>
--- a/docs/PARVAT_NETRA_SIH_Winning_Deck.pptx
+++ b/docs/PARVAT_NETRA_SIH_Winning_Deck.pptx
@@ -3478,7 +3478,7 @@
               </a:defRPr>
             </a:pPr>
             <a:r>
-              <a:t>Autonomous national disaster-intelligence platform correlating physical Mohr-Coulomb geotechnical mechanics, satellite InSAR, real-time IoT vadose infiltration, and dynamic emergency bypass logistics along the vital NH-10 corridor.</a:t>
+              <a:t>Autonomous national disaster-intelligence platform correlating physical Mohr-Coulomb geotechnical mechanics, satellite InSAR, physics-informed vadose infiltration, live IMD precipitation, and dynamic emergency bypass logistics along the vital NH-10 corridor.</a:t>
             </a:r>
           </a:p>
         </p:txBody>
@@ -3930,7 +3930,7 @@
               </a:defRPr>
             </a:pPr>
             <a:r>
-              <a:t>• 5-Modality AI Fusion</a:t>
+              <a:t>• 5-Modality Physics Fusion</a:t>
             </a:r>
           </a:p>
           <a:p>
@@ -3954,7 +3954,7 @@
               </a:defRPr>
             </a:pPr>
             <a:r>
-              <a:t>• 36h Predictive Lead</a:t>
+              <a:t>• 24-48h Predictive Lead</a:t>
             </a:r>
           </a:p>
           <a:p>
@@ -3990,7 +3990,7 @@
               </a:defRPr>
             </a:pPr>
             <a:r>
-              <a:t>• GIGW 3.0 Accessible</a:t>
+              <a:t>• GIGW 3.0 &amp; Zero-Trust RBAC</a:t>
             </a:r>
           </a:p>
         </p:txBody>
@@ -5264,7 +5264,7 @@
               </a:defRPr>
             </a:pPr>
             <a:r>
-              <a:t>  van Genuchten SWCC &amp; Green-Ampt Core</a:t>
+              <a:t>  van Genuchten SWCC &amp; Mohr-Coulomb Core</a:t>
             </a:r>
           </a:p>
           <a:p>
@@ -5276,6 +5276,54 @@
               </a:defRPr>
             </a:pPr>
             <a:r>
+              <a:t>• PAHAD AI Engine</a:t>
+            </a:r>
+          </a:p>
+          <a:p>
+            <a:pPr>
+              <a:defRPr sz="800">
+                <a:solidFill>
+                  <a:srgbClr val="1E293B"/>
+                </a:solidFill>
+              </a:defRPr>
+            </a:pPr>
+            <a:r>
+              <a:t>  GBDT [TRAINED_LIMITED_DATA] + LSTM [SURROGATE]</a:t>
+            </a:r>
+          </a:p>
+          <a:p>
+            <a:pPr>
+              <a:defRPr b="1" sz="900">
+                <a:solidFill>
+                  <a:srgbClr val="10B981"/>
+                </a:solidFill>
+              </a:defRPr>
+            </a:pPr>
+            <a:r>
+              <a:t>• Telemetry Truth</a:t>
+            </a:r>
+          </a:p>
+          <a:p>
+            <a:pPr>
+              <a:defRPr sz="800">
+                <a:solidFill>
+                  <a:srgbClr val="1E293B"/>
+                </a:solidFill>
+              </a:defRPr>
+            </a:pPr>
+            <a:r>
+              <a:t>  IMD NWP [LIVE] | In-Situ Sensors [SIMULATED]</a:t>
+            </a:r>
+          </a:p>
+          <a:p>
+            <a:pPr>
+              <a:defRPr b="1" sz="900">
+                <a:solidFill>
+                  <a:srgbClr val="10B981"/>
+                </a:solidFill>
+              </a:defRPr>
+            </a:pPr>
+            <a:r>
               <a:t>• Neon PostGIS 3.6</a:t>
             </a:r>
           </a:p>
@@ -5288,7 +5336,7 @@
               </a:defRPr>
             </a:pPr>
             <a:r>
-              <a:t>  Serverless Spatial GiST &amp; DBSCAN</a:t>
+              <a:t>  Serverless Spatial GiST &amp; DBSCAN Clusters</a:t>
             </a:r>
           </a:p>
           <a:p>
@@ -5312,7 +5360,7 @@
               </a:defRPr>
             </a:pPr>
             <a:r>
-              <a:t>  Node LEWS-REGIONAL-EAST-01</a:t>
+              <a:t>  LEWS-REGIONAL-EAST-01 Archival [HISTORICAL]</a:t>
             </a:r>
           </a:p>
           <a:p>
@@ -5324,7 +5372,7 @@
               </a:defRPr>
             </a:pPr>
             <a:r>
-              <a:t>• Sentinel &amp; NISAR</a:t>
+              <a:t>• NDMA &amp; C-DOT</a:t>
             </a:r>
           </a:p>
           <a:p>
@@ -5336,55 +5384,7 @@
               </a:defRPr>
             </a:pPr>
             <a:r>
-              <a:t>  InSAR PS Creep &amp; L-Band Penetration</a:t>
-            </a:r>
-          </a:p>
-          <a:p>
-            <a:pPr>
-              <a:defRPr b="1" sz="900">
-                <a:solidFill>
-                  <a:srgbClr val="10B981"/>
-                </a:solidFill>
-              </a:defRPr>
-            </a:pPr>
-            <a:r>
-              <a:t>• NDMA &amp; C-DOT</a:t>
-            </a:r>
-          </a:p>
-          <a:p>
-            <a:pPr>
-              <a:defRPr sz="800">
-                <a:solidFill>
-                  <a:srgbClr val="1E293B"/>
-                </a:solidFill>
-              </a:defRPr>
-            </a:pPr>
-            <a:r>
-              <a:t>  OASIS CAP v1.2 XML &amp; CBS CH-4370</a:t>
-            </a:r>
-          </a:p>
-          <a:p>
-            <a:pPr>
-              <a:defRPr b="1" sz="900">
-                <a:solidFill>
-                  <a:srgbClr val="10B981"/>
-                </a:solidFill>
-              </a:defRPr>
-            </a:pPr>
-            <a:r>
-              <a:t>• BRO Swastik SOP</a:t>
-            </a:r>
-          </a:p>
-          <a:p>
-            <a:pPr>
-              <a:defRPr sz="800">
-                <a:solidFill>
-                  <a:srgbClr val="1E293B"/>
-                </a:solidFill>
-              </a:defRPr>
-            </a:pPr>
-            <a:r>
-              <a:t>  758/764 BRTF Tactical Staging</a:t>
+              <a:t>  OASIS CAP v1.2 XML &amp; Safety Interlock [DRY_RUN]</a:t>
             </a:r>
           </a:p>
         </p:txBody>
@@ -5832,7 +5832,7 @@
               </a:defRPr>
             </a:pPr>
             <a:r>
-              <a:t>PILLAR 1: FEASIBILITY ANALYSIS</a:t>
+              <a:t>PILLAR 1: SCIENTIFIC FEASIBILITY</a:t>
             </a:r>
           </a:p>
           <a:p>
@@ -5844,7 +5844,7 @@
               </a:defRPr>
             </a:pPr>
             <a:r>
-              <a:t>Zero Sat Cost | Solar IoT | NISAR L-Band</a:t>
+              <a:t>Physics Core | In-Situ Telemetry | InSAR Vectors</a:t>
             </a:r>
           </a:p>
           <a:p>
@@ -5856,7 +5856,7 @@
               </a:defRPr>
             </a:pPr>
             <a:r>
-              <a:t>• Zero New Satellite Expenditure: Harnesses existing ESA Copernicus Sentinel-1 SAR dry-season passes with NISAR L-band (24cm) canopy penetration roadmap.</a:t>
+              <a:t>• Physics-First Grounding: Mohr-Coulomb limit equilibrium coupled with Green-Ampt infiltration and van Genuchten SWCC matric suction.</a:t>
             </a:r>
           </a:p>
           <a:p>
@@ -5868,7 +5868,7 @@
               </a:defRPr>
             </a:pPr>
             <a:r>
-              <a:t>• Solar 12V Low-Power Geotechnical Nodes: Piezometers, VWC probes and MEMS inclinometers running on 10W solar panels with 14-day battery buffers.</a:t>
+              <a:t>• Provenance Architecture: Transparent separation of [LIVE] IMD weather, [HISTORICAL] GSI inventories, and [SIMULATED] in-situ sensors.</a:t>
             </a:r>
           </a:p>
           <a:p>
@@ -5880,7 +5880,7 @@
               </a:defRPr>
             </a:pPr>
             <a:r>
-              <a:t>• Offline SQLite Field Cache: Mobile disaster apps operate in zero-connectivity gorge shadows, syncing automatically on connectivity return.</a:t>
+              <a:t>• Model Honesty: GBDT Event Classifier [TRAINED_LIMITED_DATA] and physics-informed temporal surrogate [NOT_TRAINED LSTM].</a:t>
             </a:r>
           </a:p>
           <a:p>
@@ -5892,7 +5892,7 @@
               </a:defRPr>
             </a:pPr>
             <a:r>
-              <a:t>• Elastic Neon PostGIS: Sub-50ms spatial queries across highway nodes without costly fixed on-prem infrastructure.</a:t>
+              <a:t>• Spaceborne Geodesy Roadmap: Copernicus Sentinel-1 PS InSAR creep with upcoming NISAR L-band (24cm) sub-canopy penetration.</a:t>
             </a:r>
           </a:p>
         </p:txBody>
@@ -5958,7 +5958,7 @@
               </a:defRPr>
             </a:pPr>
             <a:r>
-              <a:t>GSI NLFC | Sachet CAP (ne-IN) | C-DOT CBS</a:t>
+              <a:t>GSI NLFC | Sachet CAP (ne-IN) | Dual-Key EOC</a:t>
             </a:r>
           </a:p>
           <a:p>
@@ -5982,7 +5982,7 @@
               </a:defRPr>
             </a:pPr>
             <a:r>
-              <a:t>• NDMA Sachet CAP v1.2 XML with Nepali Gap-Fill: Generates 4-language XML (en-IN, hi-IN, ne-IN, as-IN) resolving official language omission in Sikkim.</a:t>
+              <a:t>• Dual-Key Human Authorization: Strict EOC human-in-the-loop review prevents automated sirens (ENABLE_PUBLIC_DISPATCH=0).</a:t>
             </a:r>
           </a:p>
           <a:p>
@@ -5994,7 +5994,7 @@
               </a:defRPr>
             </a:pPr>
             <a:r>
-              <a:t>• C-DOT Cell Broadcast System (CBS): CH-4370 hardware vibration and siren override for RED alerts (bypasses DND).</a:t>
+              <a:t>• NDMA Sachet CAP v1.2 XML with Nepali Gap-Fill: Generates 4-language XML (en-IN, hi-IN, ne-IN, as-IN) resolving language gaps in Sikkim.</a:t>
             </a:r>
           </a:p>
           <a:p>
@@ -6006,7 +6006,7 @@
               </a:defRPr>
             </a:pPr>
             <a:r>
-              <a:t>• Explainable Physics Attribution: Transparent FoS, SWCC matric suction, and rainfall threshold breakdown prevents black-box hesitation.</a:t>
+              <a:t>• C-DOT Cell Broadcast System (CBS): CH-4370 hardware vibration and siren override ready for verified RED emergencies.</a:t>
             </a:r>
           </a:p>
         </p:txBody>
@@ -8034,7 +8034,7 @@
               </a:defRPr>
             </a:pPr>
             <a:r>
-              <a:t>Badges: [GIGW 3.0 Standard] [Live IMD Weather Sync] [Real-Time Incident Marquee]. Bilingual accessible console engineered to national governance standards.</a:t>
+              <a:t>Badges: [GIGW 3.0 Standard] [Live IMD Weather Sync] [In-Situ Geotech: SIMULATED] [Dual-Key Safety Review]. Bilingual accessible console engineered to national governance standards.</a:t>
             </a:r>
           </a:p>
         </p:txBody>
@@ -8100,7 +8100,7 @@
               </a:defRPr>
             </a:pPr>
             <a:r>
-              <a:t>Badges: [500m PostGIS Road Buffer] [Pulsating IoT Telemetry Nodes] [InSAR Radar Vectors]. High-contrast interactive Leaflet GIS with dynamic detour routing.</a:t>
+              <a:t>Badges: [500m PostGIS Road Buffer] [In-Situ Nodes: SIMULATED] [InSAR Radar Vectors]. High-contrast interactive Leaflet GIS with dynamic detour routing.</a:t>
             </a:r>
           </a:p>
         </p:txBody>

</xml_diff>

<commit_message>
feat(phase12f): finalize SIH 2026 release freeze, validation manifest, judge defense, and master demo baseline
</commit_message>
<xml_diff>
--- a/docs/PARVAT_NETRA_SIH_Winning_Deck.pptx
+++ b/docs/PARVAT_NETRA_SIH_Winning_Deck.pptx
@@ -5288,7 +5288,7 @@
               </a:defRPr>
             </a:pPr>
             <a:r>
-              <a:t>  GBDT [TRAINED_LIMITED_DATA] + LSTM [SURROGATE]</a:t>
+              <a:t>  GBDT [17 Events / N=8 Test] + LSTM [SURROGATE]</a:t>
             </a:r>
           </a:p>
           <a:p>
@@ -5312,7 +5312,7 @@
               </a:defRPr>
             </a:pPr>
             <a:r>
-              <a:t>  IMD NWP [LIVE] | In-Situ Sensors [SIMULATED]</a:t>
+              <a:t>  IMD NWP [LIVE] | Geotech [SIMULATED (UNVERIFIED)]</a:t>
             </a:r>
           </a:p>
           <a:p>
@@ -5868,7 +5868,7 @@
               </a:defRPr>
             </a:pPr>
             <a:r>
-              <a:t>• Provenance Architecture: Transparent separation of [LIVE] IMD weather, [HISTORICAL] GSI inventories, and [SIMULATED] in-situ sensors.</a:t>
+              <a:t>• Dataset Honesty: 17 verified historical landslides, 36 labeled windows, N=8 held-out test set (TRAINED_LIMITED_DATA; non-overfitted).</a:t>
             </a:r>
           </a:p>
           <a:p>
@@ -5880,7 +5880,7 @@
               </a:defRPr>
             </a:pPr>
             <a:r>
-              <a:t>• Model Honesty: GBDT Event Classifier [TRAINED_LIMITED_DATA] and physics-informed temporal surrogate [NOT_TRAINED LSTM].</a:t>
+              <a:t>• Telemetry Truth: In-situ piezometers/tilt strictly SIMULATED via Mohr-Coulomb mechanics (Physical hillside deployment not verified).</a:t>
             </a:r>
           </a:p>
           <a:p>
@@ -5892,7 +5892,7 @@
               </a:defRPr>
             </a:pPr>
             <a:r>
-              <a:t>• Spaceborne Geodesy Roadmap: Copernicus Sentinel-1 PS InSAR creep with upcoming NISAR L-band (24cm) sub-canopy penetration.</a:t>
+              <a:t>• Sequence Modeling: Deep learning LSTM temporal surrogate (NOT_TRAINED LSTM); training gate closed until continuous deployment.</a:t>
             </a:r>
           </a:p>
         </p:txBody>

</xml_diff>